<commit_message>
feat(parte-8): detectar actividad de hardware
</commit_message>
<xml_diff>
--- a/classes/parte-8-blue-team-deteccion-y-soc/199-ingenieria-de-deteccion-como-disciplina/clase-199-presentacion.pptx
+++ b/classes/parte-8-blue-team-deteccion-y-soc/199-ingenieria-de-deteccion-como-disciplina/clase-199-presentacion.pptx
@@ -3662,6 +3662,21 @@
               <a:t>•  Explica cómo el versionado ayuda a auditar cambios de detección.</a:t>
             </a:r>
           </a:p>
+          <a:p>
+            <a:pPr>
+              <a:spcAft>
+                <a:spcPts val="600"/>
+              </a:spcAft>
+            </a:pPr>
+            <a:r>
+              <a:rPr sz="1500">
+                <a:solidFill>
+                  <a:srgbClr val="22282E"/>
+                </a:solidFill>
+              </a:rPr>
+              <a:t>•  Diseña contratos separados para conexión USB, conducta posterior y atribución física; indica qué decisión puede tomar el SOC con cada uno.</a:t>
+            </a:r>
+          </a:p>
         </p:txBody>
       </p:sp>
     </p:spTree>
@@ -4211,6 +4226,36 @@
                 </a:solidFill>
               </a:rPr>
               <a:t>•  SigmaHQ Rules: repositorio comunitario de contenido que debe adaptarse, probarse, versionarse y mantenerse localmente — &lt;https://github.com/SigmaHQ/sigma&gt;</a:t>
+            </a:r>
+          </a:p>
+          <a:p>
+            <a:pPr>
+              <a:spcAft>
+                <a:spcPts val="600"/>
+              </a:spcAft>
+            </a:pPr>
+            <a:r>
+              <a:rPr sz="1500">
+                <a:solidFill>
+                  <a:srgbClr val="22282E"/>
+                </a:solidFill>
+              </a:rPr>
+              <a:t>•  USBGuard Rule Language: campos y semántica verificables para decisiones de autorización USB; VID/PID, nombre y serie no constituyen identidad criptográfica —…</a:t>
+            </a:r>
+          </a:p>
+          <a:p>
+            <a:pPr>
+              <a:spcAft>
+                <a:spcPts val="600"/>
+              </a:spcAft>
+            </a:pPr>
+            <a:r>
+              <a:rPr sz="1500">
+                <a:solidFill>
+                  <a:srgbClr val="22282E"/>
+                </a:solidFill>
+              </a:rPr>
+              <a:t>•  Microsoft SetupAPI device installation log: alcance real del registro de instalación de dispositivos en Windows —…</a:t>
             </a:r>
           </a:p>
         </p:txBody>

</xml_diff>